<commit_message>
Deck slide 4: low-RAM framing from measured data only
688 MB LITE footprint shown as ~17% of a 4 GB phone (arithmetic on the
measured value); speed on budget chips and end-to-end latency marked as
measurement in progress. Risk rows shifted to fit the longer footnote.

Co-Authored-By: Claude Opus 5.5 <noreply@anthropic.com>
</commit_message>
<xml_diff>
--- a/docs/presentation/iTantra_SIH2026_v4.pptx
+++ b/docs/presentation/iTantra_SIH2026_v4.pptx
@@ -13355,7 +13355,7 @@
                 </a:solidFill>
                 <a:latin typeface="Arial"/>
               </a:rPr>
-              <a:t>LITE forced on test phone</a:t>
+              <a:t>≈17% of a 4 GB phone</a:t>
             </a:r>
           </a:p>
         </p:txBody>
@@ -13727,7 +13727,7 @@
         <p:spPr>
           <a:xfrm>
             <a:off x="411480" y="2926080"/>
-            <a:ext cx="11338560" cy="201168"/>
+            <a:ext cx="11338560" cy="329184"/>
           </a:xfrm>
           <a:prstGeom prst="rect">
             <a:avLst/>
@@ -13750,7 +13750,7 @@
                 </a:solidFill>
                 <a:latin typeface="Arial"/>
               </a:rPr>
-              <a:t>Test phone: Snapdragon 870 with 12 GB RAM, LITE profile forced. Validation on 4–6 GB phones is in progress. End-to-end phone-to-phone latency: measurement pending.</a:t>
+              <a:t>Test phone: Snapdragon 870, 12 GB RAM, LITE profile forced. On 4–6 GB phones LITE switches on by itself; its 688 MB footprint does not depend on the phone's RAM. Speed on budget chips and end-to-end latency: measurement in progress.</a:t>
             </a:r>
           </a:p>
         </p:txBody>
@@ -13763,7 +13763,7 @@
         </p:nvSpPr>
         <p:spPr>
           <a:xfrm>
-            <a:off x="411480" y="3246120"/>
+            <a:off x="411480" y="3319272"/>
             <a:ext cx="5120640" cy="274320"/>
           </a:xfrm>
           <a:prstGeom prst="rect">
@@ -13800,7 +13800,7 @@
         </p:nvSpPr>
         <p:spPr>
           <a:xfrm>
-            <a:off x="5806440" y="3246120"/>
+            <a:off x="5806440" y="3319272"/>
             <a:ext cx="5943600" cy="274320"/>
           </a:xfrm>
           <a:prstGeom prst="rect">
@@ -13837,7 +13837,7 @@
         </p:nvSpPr>
         <p:spPr>
           <a:xfrm>
-            <a:off x="411480" y="3584448"/>
+            <a:off x="411480" y="3639312"/>
             <a:ext cx="11365992" cy="475488"/>
           </a:xfrm>
           <a:prstGeom prst="roundRect">
@@ -13889,7 +13889,7 @@
         </p:blipFill>
         <p:spPr>
           <a:xfrm>
-            <a:off x="566928" y="3685032"/>
+            <a:off x="566928" y="3739896"/>
             <a:ext cx="274320" cy="274320"/>
           </a:xfrm>
           <a:prstGeom prst="rect">
@@ -13905,7 +13905,7 @@
         </p:nvSpPr>
         <p:spPr>
           <a:xfrm>
-            <a:off x="960120" y="3584448"/>
+            <a:off x="960120" y="3639312"/>
             <a:ext cx="4480560" cy="475488"/>
           </a:xfrm>
           <a:prstGeom prst="rect">
@@ -13942,7 +13942,7 @@
         </p:nvCxnSpPr>
         <p:spPr>
           <a:xfrm>
-            <a:off x="5257800" y="3822191"/>
+            <a:off x="5257800" y="3877056"/>
             <a:ext cx="411480" cy="0"/>
           </a:xfrm>
           <a:prstGeom prst="line">
@@ -13978,7 +13978,7 @@
         </p:nvSpPr>
         <p:spPr>
           <a:xfrm>
-            <a:off x="5806440" y="3584448"/>
+            <a:off x="5806440" y="3639312"/>
             <a:ext cx="5852160" cy="475488"/>
           </a:xfrm>
           <a:prstGeom prst="rect">
@@ -14015,7 +14015,7 @@
         </p:nvSpPr>
         <p:spPr>
           <a:xfrm>
-            <a:off x="411480" y="4133087"/>
+            <a:off x="411480" y="4169663"/>
             <a:ext cx="11365992" cy="475488"/>
           </a:xfrm>
           <a:prstGeom prst="roundRect">
@@ -14067,7 +14067,7 @@
         </p:blipFill>
         <p:spPr>
           <a:xfrm>
-            <a:off x="566928" y="4233672"/>
+            <a:off x="566928" y="4270248"/>
             <a:ext cx="274320" cy="274320"/>
           </a:xfrm>
           <a:prstGeom prst="rect">
@@ -14083,7 +14083,7 @@
         </p:nvSpPr>
         <p:spPr>
           <a:xfrm>
-            <a:off x="960120" y="4133087"/>
+            <a:off x="960120" y="4169663"/>
             <a:ext cx="4480560" cy="475488"/>
           </a:xfrm>
           <a:prstGeom prst="rect">
@@ -14120,7 +14120,7 @@
         </p:nvCxnSpPr>
         <p:spPr>
           <a:xfrm>
-            <a:off x="5257800" y="4370831"/>
+            <a:off x="5257800" y="4407407"/>
             <a:ext cx="411480" cy="0"/>
           </a:xfrm>
           <a:prstGeom prst="line">
@@ -14156,7 +14156,7 @@
         </p:nvSpPr>
         <p:spPr>
           <a:xfrm>
-            <a:off x="5806440" y="4133087"/>
+            <a:off x="5806440" y="4169663"/>
             <a:ext cx="5852160" cy="475488"/>
           </a:xfrm>
           <a:prstGeom prst="rect">
@@ -14193,7 +14193,7 @@
         </p:nvSpPr>
         <p:spPr>
           <a:xfrm>
-            <a:off x="411480" y="4681728"/>
+            <a:off x="411480" y="4700016"/>
             <a:ext cx="11365992" cy="475488"/>
           </a:xfrm>
           <a:prstGeom prst="roundRect">
@@ -14245,7 +14245,7 @@
         </p:blipFill>
         <p:spPr>
           <a:xfrm>
-            <a:off x="566928" y="4782312"/>
+            <a:off x="566928" y="4800600"/>
             <a:ext cx="274320" cy="274320"/>
           </a:xfrm>
           <a:prstGeom prst="rect">
@@ -14261,7 +14261,7 @@
         </p:nvSpPr>
         <p:spPr>
           <a:xfrm>
-            <a:off x="960120" y="4681728"/>
+            <a:off x="960120" y="4700016"/>
             <a:ext cx="4480560" cy="475488"/>
           </a:xfrm>
           <a:prstGeom prst="rect">
@@ -14298,7 +14298,7 @@
         </p:nvCxnSpPr>
         <p:spPr>
           <a:xfrm>
-            <a:off x="5257800" y="4919472"/>
+            <a:off x="5257800" y="4937759"/>
             <a:ext cx="411480" cy="0"/>
           </a:xfrm>
           <a:prstGeom prst="line">
@@ -14334,7 +14334,7 @@
         </p:nvSpPr>
         <p:spPr>
           <a:xfrm>
-            <a:off x="5806440" y="4681728"/>
+            <a:off x="5806440" y="4700016"/>
             <a:ext cx="5852160" cy="475488"/>
           </a:xfrm>
           <a:prstGeom prst="rect">

</xml_diff>

<commit_message>
Deck slide 4 + website: 4 GB-class memory test results
Measured on the test phone with RAM locked to ~1.7 GB free (LITE):
STT 14x faster than speech, 0.62 s speech-end to text, 765 MB idle /
1.8 GB peak, 0.3% idle CPU, app not killed. Voice start 3-6 s in LITE
listed as a challenge. Method and limits (chip not slowed) stated.

Co-Authored-By: Claude Opus 5.5 <noreply@anthropic.com>
</commit_message>
<xml_diff>
--- a/docs/presentation/iTantra_SIH2026_v4.pptx
+++ b/docs/presentation/iTantra_SIH2026_v4.pptx
@@ -12818,7 +12818,7 @@
                 </a:solidFill>
                 <a:latin typeface="Arial"/>
               </a:rPr>
-              <a:t>Measured in the running prototype (in-app logging)</a:t>
+              <a:t>Measured in a 4 GB-class memory test (in-app logging)</a:t>
             </a:r>
           </a:p>
         </p:txBody>
@@ -12923,7 +12923,7 @@
                 </a:solidFill>
                 <a:latin typeface="Arial"/>
               </a:rPr>
-              <a:t>20×</a:t>
+              <a:t>14×</a:t>
             </a:r>
           </a:p>
         </p:txBody>
@@ -12997,7 +12997,7 @@
                 </a:solidFill>
                 <a:latin typeface="Arial"/>
               </a:rPr>
-              <a:t>STT real-time factor 0.05</a:t>
+              <a:t>STT real-time factor 0.07</a:t>
             </a:r>
           </a:p>
         </p:txBody>
@@ -13102,7 +13102,7 @@
                 </a:solidFill>
                 <a:latin typeface="Arial"/>
               </a:rPr>
-              <a:t>0.4–0.9 s</a:t>
+              <a:t>0.6 s</a:t>
             </a:r>
           </a:p>
         </p:txBody>
@@ -13176,7 +13176,7 @@
                 </a:solidFill>
                 <a:latin typeface="Arial"/>
               </a:rPr>
-              <a:t>Snapdragon 870</a:t>
+              <a:t>median, 10 languages</a:t>
             </a:r>
           </a:p>
         </p:txBody>
@@ -13281,7 +13281,7 @@
                 </a:solidFill>
                 <a:latin typeface="Arial"/>
               </a:rPr>
-              <a:t>688 MB</a:t>
+              <a:t>765 MB</a:t>
             </a:r>
           </a:p>
         </p:txBody>
@@ -13318,7 +13318,7 @@
                 </a:solidFill>
                 <a:latin typeface="Arial"/>
               </a:rPr>
-              <a:t>app RAM, LITE profile</a:t>
+              <a:t>app RAM when idle</a:t>
             </a:r>
           </a:p>
         </p:txBody>
@@ -13355,7 +13355,7 @@
                 </a:solidFill>
                 <a:latin typeface="Arial"/>
               </a:rPr>
-              <a:t>≈17% of a 4 GB phone</a:t>
+              <a:t>1.8 GB peak while speaking</a:t>
             </a:r>
           </a:p>
         </p:txBody>
@@ -13497,7 +13497,7 @@
                 </a:solidFill>
                 <a:latin typeface="Arial"/>
               </a:rPr>
-              <a:t>idle CPU, LITE profile</a:t>
+              <a:t>idle CPU</a:t>
             </a:r>
           </a:p>
         </p:txBody>
@@ -13534,7 +13534,7 @@
                 </a:solidFill>
                 <a:latin typeface="Arial"/>
               </a:rPr>
-              <a:t>1.6% in FULL</a:t>
+              <a:t>of one core</a:t>
             </a:r>
           </a:p>
         </p:txBody>
@@ -13585,7 +13585,7 @@
       </p:sp>
       <p:pic>
         <p:nvPicPr>
-          <p:cNvPr id="17433" name="Picture 17432" descr="flask-te.png"/>
+          <p:cNvPr id="17433" name="Picture 17432" descr="shield-te.png"/>
           <p:cNvPicPr>
             <a:picLocks noChangeAspect="1"/>
           </p:cNvPicPr>
@@ -13639,7 +13639,7 @@
                 </a:solidFill>
                 <a:latin typeface="Arial"/>
               </a:rPr>
-              <a:t>5.9%</a:t>
+              <a:t>Alive</a:t>
             </a:r>
           </a:p>
         </p:txBody>
@@ -13676,7 +13676,7 @@
                 </a:solidFill>
                 <a:latin typeface="Arial"/>
               </a:rPr>
-              <a:t>word error rate</a:t>
+              <a:t>app not killed</a:t>
             </a:r>
           </a:p>
         </p:txBody>
@@ -13713,7 +13713,7 @@
                 </a:solidFill>
                 <a:latin typeface="Arial"/>
               </a:rPr>
-              <a:t>preliminary: 10 clips</a:t>
+              <a:t>115 other apps closed</a:t>
             </a:r>
           </a:p>
         </p:txBody>
@@ -13750,7 +13750,7 @@
                 </a:solidFill>
                 <a:latin typeface="Arial"/>
               </a:rPr>
-              <a:t>Test phone: Snapdragon 870, 12 GB RAM, LITE profile forced. On 4–6 GB phones LITE switches on by itself; its 688 MB footprint does not depend on the phone's RAM. Speed on budget chips and end-to-end latency: measurement in progress.</a:t>
+              <a:t>4 GB-class test: 12 GB Snapdragon 870 phone with RAM locked so only ~1.7 GB was free, LITE profile. The chip was not slowed — a budget phone will be slower. Word error rate 5.9% (preliminary, 10 clips) unchanged.</a:t>
             </a:r>
           </a:p>
         </p:txBody>
@@ -13875,7 +13875,7 @@
       </p:sp>
       <p:pic>
         <p:nvPicPr>
-          <p:cNvPr id="17441" name="Picture 17440" descr="memory-sa.png"/>
+          <p:cNvPr id="17441" name="Picture 17440" descr="speaker-sa.png"/>
           <p:cNvPicPr>
             <a:picLocks noChangeAspect="1"/>
           </p:cNvPicPr>
@@ -13929,7 +13929,7 @@
                 </a:solidFill>
                 <a:latin typeface="Arial"/>
               </a:rPr>
-              <a:t>Phones with 3–6 GB RAM</a:t>
+              <a:t>Voice starts 3–6 s after arrival in LITE</a:t>
             </a:r>
           </a:p>
         </p:txBody>
@@ -14002,7 +14002,7 @@
                 </a:solidFill>
                 <a:latin typeface="Arial"/>
               </a:rPr>
-              <a:t>LITE profile auto-selects below 6 GB: 2 threads, no live captions, engines unload after 60 s</a:t>
+              <a:t>Keep the listener's language loaded; smaller fast voices for hi/gu/or/en (planned)</a:t>
             </a:r>
           </a:p>
         </p:txBody>

</xml_diff>